<commit_message>
Re-export the deck (PDF, PNG, PPTX) with the newer figures
Co-Authored-By: Claude Opus 5.5 <noreply@anthropic.com>
</commit_message>
<xml_diff>
--- a/app/public/Ruko-Pitch-Deck.pptx
+++ b/app/public/Ruko-Pitch-Deck.pptx
@@ -661,13 +661,13 @@
           <a:lstStyle/>
           <a:p>
             <a:r>
-              <a:t>3-minute pitch (20 s): Digital-arrest complaints doubled in a year, to 1,23,672 in 2024: about 340 a day, with about ₹1,935 crore lost. Senior citizens filed over a lakh fraud complaints in 2025 and lost about ₹4,005 crore. Early 2025 data suggests a fall, so awareness helps; we think AI voices could reverse it, which is our hypothesis.</a:t>
+              <a:t>3-minute pitch (20 s): Digital-arrest complaints doubled to 1,23,672 in 2024, with ₹1,935 crore lost. In 2025 they fell to 58,239, so awareness works, but this year there are already over 21,900 complaints and ₹647 crore lost by August. And fraud overall is still growing: 21.8 lakh complaints and about ₹19,800 crore lost in 2025. Our assumption: AI makes it cheap to fake any voice or face, on a phone or a laptop. Deepfake fraud attempts rose 1,300% in 2024, and one company paid out 25 million dollars after a deepfake video call.</a:t>
             </a:r>
           </a:p>
           <a:p/>
           <a:p>
             <a:r>
-              <a:t>Loom (30 s): Digital-arrest complaints doubled in a year, to 1,23,672 in 2024: about 340 a day, with about ₹1,935 crore lost. Senior citizens filed over a lakh fraud complaints in 2025 and lost about ₹4,005 crore. Early 2025 data suggests a fall, so awareness helps; we think AI voices could reverse it, which is our hypothesis.</a:t>
+              <a:t>Loom (35 s): Digital-arrest complaints doubled to 1,23,672 in 2024, with ₹1,935 crore lost. In 2025 they fell to 58,239, so awareness works, but this year there are already over 21,900 complaints and ₹647 crore lost by August. And fraud overall is still growing: 21.8 lakh complaints and about ₹19,800 crore lost in 2025. Our assumption: AI makes it cheap to fake any voice or face, on a phone or a laptop. Deepfake fraud attempts rose 1,300% in 2024, and one company paid out 25 million dollars after a deepfake video call.</a:t>
             </a:r>
           </a:p>
         </p:txBody>

</xml_diff>